<commit_message>
Deck: enquadramento antifraude (radar dos agentes) + numero de autonomia
Co-Authored-By: Claude Fable 5.1 <noreply@anthropic.com>
</commit_message>
<xml_diff>
--- a/docs/evidencegate-deck.pptx
+++ b/docs/evidencegate-deck.pptx
@@ -3295,7 +3295,7 @@
                 </a:solidFill>
                 <a:latin typeface="Inter"/>
               </a:rPr>
-              <a:t>Fé pública programável para a economia de agentes.</a:t>
+              <a:t>O radar antifraude da economia de agentes.</a:t>
             </a:r>
           </a:p>
         </p:txBody>
@@ -3378,7 +3378,7 @@
                 </a:solidFill>
                 <a:latin typeface="Inter"/>
               </a:rPr>
-              <a:t>Quando agentes pagam agentes, quem confere o trabalho?</a:t>
+              <a:t>Quando agentes pagam agentes, quem barra o golpe?</a:t>
             </a:r>
           </a:p>
         </p:txBody>
@@ -3573,7 +3573,7 @@
                 </a:solidFill>
                 <a:latin typeface="Inter"/>
               </a:rPr>
-              <a:t>Ninguém confere o trabalho.</a:t>
+              <a:t>Ninguém barra a fraude.</a:t>
             </a:r>
           </a:p>
         </p:txBody>
@@ -3734,7 +3734,7 @@
                 </a:solidFill>
                 <a:latin typeface="Inter"/>
               </a:rPr>
-              <a:t>O trilho existe — o controle de qualidade, não.</a:t>
+              <a:t>O trilho existe — o antifraude, não.</a:t>
             </a:r>
           </a:p>
         </p:txBody>
@@ -5521,7 +5521,7 @@
                 </a:solidFill>
                 <a:latin typeface="Inter"/>
               </a:rPr>
-              <a:t>6 escrows</a:t>
+              <a:t>49 decisões</a:t>
             </a:r>
           </a:p>
         </p:txBody>
@@ -5560,7 +5560,7 @@
                 </a:solidFill>
                 <a:latin typeface="Inter"/>
               </a:rPr>
-              <a:t>liquidados com juízes reais</a:t>
+              <a:t>autônomas · 0 intervenções humanas</a:t>
             </a:r>
           </a:p>
         </p:txBody>
@@ -6078,7 +6078,7 @@
                 </a:solidFill>
                 <a:latin typeface="Inter"/>
               </a:rPr>
-              <a:t>RASTREABILIDADE &amp; CONFIANÇA</a:t>
+              <a:t>THREAT INTELLIGENCE</a:t>
             </a:r>
           </a:p>
         </p:txBody>
@@ -6180,7 +6180,7 @@
                 </a:solidFill>
                 <a:latin typeface="Inter"/>
               </a:rPr>
-              <a:t>Grafo de proveniência</a:t>
+              <a:t>Grafo de ameaças</a:t>
             </a:r>
           </a:p>
         </p:txBody>
@@ -7409,7 +7409,7 @@
                 </a:solidFill>
                 <a:latin typeface="Inter"/>
               </a:rPr>
-              <a:t>Os trilhos estão prontos. A camada de confiança, não.</a:t>
+              <a:t>Os trilhos estão prontos. O antifraude, não.</a:t>
             </a:r>
           </a:p>
         </p:txBody>
@@ -7705,7 +7705,7 @@
                 </a:solidFill>
                 <a:latin typeface="Inter"/>
               </a:rPr>
-              <a:t>Registry de reputação: cada escrow settled melhora o score de todos. Dados de confiança que ninguém constrói sozinho — rede, não feature.</a:t>
+              <a:t>Rede antifraude: cada golpe barrado num cliente protege todos. É o Stripe Radar dos agentes — dados que ninguém constrói sozinho. Rede, não feature.</a:t>
             </a:r>
           </a:p>
         </p:txBody>
@@ -8215,7 +8215,7 @@
                 </a:solidFill>
                 <a:latin typeface="Inter"/>
               </a:rPr>
-              <a:t>EvidenceGate — fé pública programável.</a:t>
+              <a:t>EvidenceGate — o radar antifraude dos agentes.</a:t>
             </a:r>
           </a:p>
         </p:txBody>

</xml_diff>